<commit_message>
Name the hotel in the graduation trip plan
Co-Authored-By: Claude Opus 5.5 <noreply@anthropic.com>
Claude-Session: https://claude.ai/code/session_011e9DFoYiFZGGUkVnK3tway
</commit_message>
<xml_diff>
--- a/卒業旅行課題/卒業旅行プラン.pptx
+++ b/卒業旅行課題/卒業旅行プラン.pptx
@@ -116,40 +116,40 @@
   <p:extLst>
     <p:ext uri="{521415D9-36F7-43E2-AB2F-B90AF26B5E84}">
       <p14:sectionLst xmlns:p14="http://schemas.microsoft.com/office/powerpoint/2010/main">
-        <p14:section name="はじめに" id="{80dc2105-91a0-f52a-a063-fd4a18e1f1db}">
+        <p14:section name="はじめに" id="{a77a73cd-0736-69dd-3fb2-b6e9ecf1985a}">
           <p14:sldIdLst>
             <p14:sldId id="256"/>
           </p14:sldIdLst>
         </p14:section>
-        <p14:section name="プラン概要" id="{2c9ccdfa-9c5b-f35d-cdf8-6b6cdb3ed88e}">
+        <p14:section name="プラン概要" id="{41c52c0b-f95b-b1c9-f819-b228776cd8b0}">
           <p14:sldIdLst>
             <p14:sldId id="257"/>
           </p14:sldIdLst>
         </p14:section>
-        <p14:section name="行程表" id="{031be19f-b383-ac32-4340-96cf7436337a}">
+        <p14:section name="行程表" id="{e569073a-4d3f-1b66-b663-b4414be0aea4}">
           <p14:sldIdLst>
             <p14:sldId id="258"/>
           </p14:sldIdLst>
         </p14:section>
-        <p14:section name="観光地の紹介" id="{29131159-9899-8df5-66c3-766f5e729f12}">
+        <p14:section name="観光地の紹介" id="{46df309b-46f2-2081-2206-e80e5f056885}">
           <p14:sldIdLst>
             <p14:sldId id="259"/>
             <p14:sldId id="260"/>
             <p14:sldId id="261"/>
           </p14:sldIdLst>
         </p14:section>
-        <p14:section name="宿泊・予算" id="{1ff94096-a5f5-b387-d53e-8aee18281eff}">
+        <p14:section name="宿泊・予算" id="{ec184a3d-5b34-d70b-2ed2-ab7baa9c8971}">
           <p14:sldIdLst>
             <p14:sldId id="262"/>
             <p14:sldId id="263"/>
           </p14:sldIdLst>
         </p14:section>
-        <p14:section name="まとめ" id="{c2427fbc-94d0-b6cf-348c-a874b5e49ef5}">
+        <p14:section name="まとめ" id="{7a6c51c1-002d-a56a-b0a2-06c8930233cb}">
           <p14:sldIdLst>
             <p14:sldId id="264"/>
           </p14:sldIdLst>
         </p14:section>
-        <p14:section name="写真出典" id="{62b3a9f0-48d1-b65a-53ed-ded041d37c1d}">
+        <p14:section name="写真出典" id="{d5915a46-0a0e-7069-e758-928e5b7e7c88}">
           <p14:sldIdLst>
             <p14:sldId id="265"/>
           </p14:sldIdLst>
@@ -1179,7 +1179,7 @@
           <a:p>
             <a:r>
               <a:rPr lang="en-US" dirty="0"/>
-              <a:t>ホテルは、なんば駅から徒歩5分のシティホテルに2泊します。4人1室、朝食付きで1人1泊約6千円です。
+              <a:t>ホテルは、なんば駅から徒歩約3分の「なんば道頓堀ホテル」に2泊します。4人1室、朝食付きで1人1泊約6千円です。
 2泊とも同じホテルなので、荷物を持ち歩く必要もありません。</a:t>
             </a:r>
             <a:endParaRPr lang="en-US" dirty="0"/>
@@ -3037,7 +3037,7 @@
                   <a:schemeClr val="tx1"/>
                 </a:solidFill>
               </a:rPr>
-              <a:t>なんば駅周辺のホテル　4人1室</a:t>
+              <a:t>なんば道頓堀ホテル　4人1室</a:t>
             </a:r>
             <a:endParaRPr lang="en-US" sz="1400" dirty="0"/>
           </a:p>
@@ -7221,8 +7221,8 @@
         </p:nvSpPr>
         <p:spPr>
           <a:xfrm>
-            <a:off x="457200" y="1051560"/>
-            <a:ext cx="4206240" cy="365760"/>
+            <a:off x="457200" y="1005840"/>
+            <a:ext cx="4389120" cy="411480"/>
           </a:xfrm>
           <a:prstGeom prst="rect">
             <a:avLst/>
@@ -7238,14 +7238,28 @@
               <a:buNone/>
             </a:pPr>
             <a:r>
-              <a:rPr lang="en-US" sz="1300" dirty="0">
+              <a:rPr lang="en-US" sz="2000" b="1" dirty="0">
                 <a:solidFill>
                   <a:schemeClr val="tx1"/>
                 </a:solidFill>
+                <a:latin typeface="Yu Mincho" pitchFamily="34" charset="0"/>
+                <a:ea typeface="Yu Mincho" pitchFamily="34" charset="-122"/>
+                <a:cs typeface="Yu Mincho" pitchFamily="34" charset="-120"/>
               </a:rPr>
-              <a:t>なんば駅周辺のシティホテル（2泊・朝食付き）</a:t>
-            </a:r>
-            <a:endParaRPr lang="en-US" sz="1300" dirty="0"/>
+              <a:t>なんば道頓堀ホテル</a:t>
+            </a:r>
+            <a:pPr indent="0" marL="0">
+              <a:buNone/>
+            </a:pPr>
+            <a:r>
+              <a:rPr lang="en-US" sz="1200" dirty="0">
+                <a:solidFill>
+                  <a:schemeClr val="tx1"/>
+                </a:solidFill>
+              </a:rPr>
+              <a:t>　2泊・朝食付き</a:t>
+            </a:r>
+            <a:endParaRPr lang="en-US" sz="2000" dirty="0"/>
           </a:p>
         </p:txBody>
       </p:sp>
@@ -7363,7 +7377,7 @@
                   <a:schemeClr val="tx1"/>
                 </a:solidFill>
               </a:rPr>
-              <a:t>駅から徒歩5分</a:t>
+              <a:t>なんば駅から徒歩約3分</a:t>
             </a:r>
             <a:endParaRPr lang="en-US" sz="1400" dirty="0"/>
           </a:p>
@@ -7399,7 +7413,7 @@
                   <a:schemeClr val="tx1"/>
                 </a:solidFill>
               </a:rPr>
-              <a:t>道頓堀まで歩いて行けるので、夜も安心。</a:t>
+              <a:t>道頓堀・グリコの看板もすぐ近く。夜も安心。</a:t>
             </a:r>
             <a:endParaRPr lang="en-US" sz="1200" dirty="0"/>
           </a:p>
@@ -7625,7 +7639,7 @@
                   <a:schemeClr val="bg1"/>
                 </a:solidFill>
               </a:rPr>
-              <a:t>写真は大阪市内のホテル客室の例です</a:t>
+              <a:t>写真は客室のイメージです（別のホテル）</a:t>
             </a:r>
             <a:endParaRPr lang="en-US" sz="900" dirty="0"/>
           </a:p>

</xml_diff>